<commit_message>
product default: Katalyze (tuned) with listener-based clickables; plain agent names; deck and docs
SessionSettings.listener_clickables (default on) gives every product agent the round-2
action space; the default agent hybrid_final is therefore hybrid_final_v5's configuration.
UI names: Katalyze, tuned (recommended) / Bandit explorer / Curiosity RL explorer / Deep
Q-network (research) / Random exploration (baseline). Deck app slide states the default;
README agents table and PROJECT_CONTEXT (status, where to look, 10-25 -> 10-26 history)
updated; UI screenshots retaken.

Co-Authored-By: Claude Opus 5.5 <noreply@anthropic.com>
</commit_message>
<xml_diff>
--- a/Katalyze_Final_Review.pptx
+++ b/Katalyze_Final_Review.pptx
@@ -135,37 +135,37 @@
   <p:extLst>
     <p:ext uri="{521415D9-36F7-43E2-AB2F-B90AF26B5E84}">
       <p14:sectionLst xmlns:p14="http://schemas.microsoft.com/office/powerpoint/2010/main">
-        <p14:section name="Title" id="{42cfb13e-f098-3180-068f-a18c98d2e1db}">
+        <p14:section name="Title" id="{60706910-08fe-3fff-5831-bf597a5b6355}">
           <p14:sldIdLst>
             <p14:sldId id="256"/>
           </p14:sldIdLst>
         </p14:section>
-        <p14:section name="Contents" id="{71b25caa-0d39-e144-c188-744c4df290cb}">
+        <p14:section name="Contents" id="{9b03f963-d60c-e7ce-bf4a-0dec25d72aa3}">
           <p14:sldIdLst>
             <p14:sldId id="257"/>
           </p14:sldIdLst>
         </p14:section>
-        <p14:section name="Introduction" id="{d957f755-9c50-3c96-ba98-37eabac233ea}">
+        <p14:section name="Introduction" id="{e188ce06-1ba9-cb3d-956e-a4604ca3cc5b}">
           <p14:sldIdLst>
             <p14:sldId id="258"/>
           </p14:sldIdLst>
         </p14:section>
-        <p14:section name="Problem statement" id="{5baf1f5c-fe44-0791-174e-ca4e0de0f13f}">
+        <p14:section name="Problem statement" id="{e9d0c95d-dcf5-31dd-27b9-11afbafb9014}">
           <p14:sldIdLst>
             <p14:sldId id="259"/>
           </p14:sldIdLst>
         </p14:section>
-        <p14:section name="Literature review" id="{afed06a9-3b94-5c11-0895-917897838ca3}">
+        <p14:section name="Literature review" id="{533da120-24da-f636-b212-05d04ac2ae1f}">
           <p14:sldIdLst>
             <p14:sldId id="260"/>
           </p14:sldIdLst>
         </p14:section>
-        <p14:section name="Research gaps" id="{d37da8b5-5c63-1f6f-4de6-1648a4c289e9}">
+        <p14:section name="Research gaps" id="{388d4113-943c-daeb-7736-fd8a2bec2d70}">
           <p14:sldIdLst>
             <p14:sldId id="261"/>
           </p14:sldIdLst>
         </p14:section>
-        <p14:section name="Methodology" id="{91d867e1-4711-5dce-a8c8-fc7afee638a1}">
+        <p14:section name="Methodology" id="{957ff3b9-a8de-fd27-4156-c7b46350615d}">
           <p14:sldIdLst>
             <p14:sldId id="262"/>
             <p14:sldId id="263"/>
@@ -176,18 +176,18 @@
             <p14:sldId id="268"/>
           </p14:sldIdLst>
         </p14:section>
-        <p14:section name="Workflow" id="{65a66846-dd91-57f1-8a93-6dd5ebf93dac}">
+        <p14:section name="Workflow" id="{42357e66-f69b-df70-8725-3c29be92574b}">
           <p14:sldIdLst>
             <p14:sldId id="269"/>
           </p14:sldIdLst>
         </p14:section>
-        <p14:section name="Evaluation design" id="{27ca67b6-e8ce-f08d-df4b-e4d2664895de}">
+        <p14:section name="Evaluation design" id="{ba67ff08-cb42-190a-7f30-5163de8b835f}">
           <p14:sldIdLst>
             <p14:sldId id="270"/>
             <p14:sldId id="271"/>
           </p14:sldIdLst>
         </p14:section>
-        <p14:section name="Results" id="{00b42073-094c-0842-7c71-b8373c839c8f}">
+        <p14:section name="Results" id="{527a52ed-a417-b32b-54e2-2b4ee9b04a02}">
           <p14:sldIdLst>
             <p14:sldId id="272"/>
             <p14:sldId id="273"/>
@@ -196,33 +196,33 @@
             <p14:sldId id="276"/>
           </p14:sldIdLst>
         </p14:section>
-        <p14:section name="Results analysis" id="{79f4dcf7-8a1f-34ef-f505-37f6ec9ee446}">
+        <p14:section name="Results analysis" id="{ddb0b23f-212a-d422-a743-3a356baa8a36}">
           <p14:sldIdLst>
             <p14:sldId id="277"/>
             <p14:sldId id="278"/>
           </p14:sldIdLst>
         </p14:section>
-        <p14:section name="Our app" id="{106c0d6f-8540-f0b8-acb0-ac30aaacac85}">
+        <p14:section name="Our app" id="{87bab7ed-eb08-e2f8-b6ae-4c41e6eadc23}">
           <p14:sldIdLst>
             <p14:sldId id="279"/>
           </p14:sldIdLst>
         </p14:section>
-        <p14:section name="Conclusion" id="{ce1e0941-9e17-374c-9ee8-a457c035baf0}">
+        <p14:section name="Conclusion" id="{01771b93-07fc-113d-4830-d5b61441c38b}">
           <p14:sldIdLst>
             <p14:sldId id="280"/>
           </p14:sldIdLst>
         </p14:section>
-        <p14:section name="Future work" id="{3ab63bcd-bba3-69f4-b961-676c0dbd4ca4}">
+        <p14:section name="Future work" id="{b8b12bfe-1337-3bba-bed9-c8aa11c94564}">
           <p14:sldIdLst>
             <p14:sldId id="281"/>
           </p14:sldIdLst>
         </p14:section>
-        <p14:section name="Team" id="{82c75daa-0f82-80f9-f137-4df7a3654d6c}">
+        <p14:section name="Team" id="{19907fab-de90-29df-238f-cd2d5eda18a5}">
           <p14:sldIdLst>
             <p14:sldId id="282"/>
           </p14:sldIdLst>
         </p14:section>
-        <p14:section name="References" id="{90194fe8-1077-8cab-91b1-108f8ee1ae47}">
+        <p14:section name="References" id="{fdede29c-8bc6-c075-face-ef8bcea64645}">
           <p14:sldIdLst>
             <p14:sldId id="283"/>
             <p14:sldId id="284"/>
@@ -19088,8 +19088,8 @@
         </p:nvSpPr>
         <p:spPr>
           <a:xfrm>
-            <a:off x="685800" y="4572000"/>
-            <a:ext cx="1463040" cy="457200"/>
+            <a:off x="685800" y="4526280"/>
+            <a:ext cx="1463040" cy="384048"/>
           </a:xfrm>
           <a:prstGeom prst="roundRect">
             <a:avLst>
@@ -19115,8 +19115,8 @@
         </p:nvSpPr>
         <p:spPr>
           <a:xfrm>
-            <a:off x="868680" y="4572000"/>
-            <a:ext cx="1097280" cy="457200"/>
+            <a:off x="868680" y="4526280"/>
+            <a:ext cx="1097280" cy="384048"/>
           </a:xfrm>
           <a:prstGeom prst="rect">
             <a:avLst/>
@@ -19132,14 +19132,14 @@
               <a:buNone/>
             </a:pPr>
             <a:r>
-              <a:rPr lang="en-US" sz="1400" dirty="0">
+              <a:rPr lang="en-US" sz="1350" dirty="0">
                 <a:solidFill>
                   <a:schemeClr val="bg1"/>
                 </a:solidFill>
               </a:rPr>
-              <a:t>Inputs</a:t>
-            </a:r>
-            <a:endParaRPr lang="en-US" sz="1400" dirty="0"/>
+              <a:t>Default</a:t>
+            </a:r>
+            <a:endParaRPr lang="en-US" sz="1350" dirty="0"/>
           </a:p>
         </p:txBody>
       </p:sp>
@@ -19151,8 +19151,8 @@
         </p:nvSpPr>
         <p:spPr>
           <a:xfrm>
-            <a:off x="2331720" y="4572000"/>
-            <a:ext cx="8778240" cy="457200"/>
+            <a:off x="2331720" y="4526280"/>
+            <a:ext cx="8778240" cy="384048"/>
           </a:xfrm>
           <a:prstGeom prst="rect">
             <a:avLst/>
@@ -19168,14 +19168,14 @@
               <a:buNone/>
             </a:pPr>
             <a:r>
-              <a:rPr lang="en-US" sz="1400" dirty="0">
+              <a:rPr lang="en-US" sz="1350" b="1" dirty="0">
                 <a:solidFill>
                   <a:schemeClr val="tx1"/>
                 </a:solidFill>
               </a:rPr>
-              <a:t>live URL · static site · zip upload · repository with a Dockerfile · bundled demo apps</a:t>
-            </a:r>
-            <a:endParaRPr lang="en-US" sz="1400" dirty="0"/>
+              <a:t>Katalyze (tuned) with listener-based clickable detection; also offers the bandit explorer, curiosity RL explorer and random exploration</a:t>
+            </a:r>
+            <a:endParaRPr lang="en-US" sz="1350" dirty="0"/>
           </a:p>
         </p:txBody>
       </p:sp>
@@ -19187,8 +19187,8 @@
         </p:nvSpPr>
         <p:spPr>
           <a:xfrm>
-            <a:off x="685800" y="5166360"/>
-            <a:ext cx="1463040" cy="457200"/>
+            <a:off x="685800" y="4983480"/>
+            <a:ext cx="1463040" cy="384048"/>
           </a:xfrm>
           <a:prstGeom prst="roundRect">
             <a:avLst>
@@ -19214,8 +19214,8 @@
         </p:nvSpPr>
         <p:spPr>
           <a:xfrm>
-            <a:off x="868680" y="5166360"/>
-            <a:ext cx="1097280" cy="457200"/>
+            <a:off x="868680" y="4983480"/>
+            <a:ext cx="1097280" cy="384048"/>
           </a:xfrm>
           <a:prstGeom prst="rect">
             <a:avLst/>
@@ -19231,14 +19231,14 @@
               <a:buNone/>
             </a:pPr>
             <a:r>
-              <a:rPr lang="en-US" sz="1400" dirty="0">
+              <a:rPr lang="en-US" sz="1350" dirty="0">
                 <a:solidFill>
                   <a:schemeClr val="bg1"/>
                 </a:solidFill>
               </a:rPr>
-              <a:t>Safety</a:t>
-            </a:r>
-            <a:endParaRPr lang="en-US" sz="1400" dirty="0"/>
+              <a:t>Inputs</a:t>
+            </a:r>
+            <a:endParaRPr lang="en-US" sz="1350" dirty="0"/>
           </a:p>
         </p:txBody>
       </p:sp>
@@ -19250,8 +19250,8 @@
         </p:nvSpPr>
         <p:spPr>
           <a:xfrm>
-            <a:off x="2331720" y="5166360"/>
-            <a:ext cx="8778240" cy="457200"/>
+            <a:off x="2331720" y="4983480"/>
+            <a:ext cx="8778240" cy="384048"/>
           </a:xfrm>
           <a:prstGeom prst="rect">
             <a:avLst/>
@@ -19267,14 +19267,14 @@
               <a:buNone/>
             </a:pPr>
             <a:r>
-              <a:rPr lang="en-US" sz="1400" dirty="0">
+              <a:rPr lang="en-US" sz="1350" dirty="0">
                 <a:solidFill>
                   <a:schemeClr val="tx1"/>
                 </a:solidFill>
               </a:rPr>
-              <a:t>uploads run in a restricted container: no capabilities, read-only filesystem, internal network</a:t>
-            </a:r>
-            <a:endParaRPr lang="en-US" sz="1400" dirty="0"/>
+              <a:t>live URL · static site · zip upload · repository with a Dockerfile · bundled demo apps</a:t>
+            </a:r>
+            <a:endParaRPr lang="en-US" sz="1350" dirty="0"/>
           </a:p>
         </p:txBody>
       </p:sp>
@@ -19286,8 +19286,8 @@
         </p:nvSpPr>
         <p:spPr>
           <a:xfrm>
-            <a:off x="685800" y="5760720"/>
-            <a:ext cx="1463040" cy="457200"/>
+            <a:off x="685800" y="5440680"/>
+            <a:ext cx="1463040" cy="384048"/>
           </a:xfrm>
           <a:prstGeom prst="roundRect">
             <a:avLst>
@@ -19313,8 +19313,8 @@
         </p:nvSpPr>
         <p:spPr>
           <a:xfrm>
-            <a:off x="868680" y="5760720"/>
-            <a:ext cx="1097280" cy="457200"/>
+            <a:off x="868680" y="5440680"/>
+            <a:ext cx="1097280" cy="384048"/>
           </a:xfrm>
           <a:prstGeom prst="rect">
             <a:avLst/>
@@ -19330,14 +19330,14 @@
               <a:buNone/>
             </a:pPr>
             <a:r>
-              <a:rPr lang="en-US" sz="1400" dirty="0">
+              <a:rPr lang="en-US" sz="1350" dirty="0">
                 <a:solidFill>
                   <a:schemeClr val="bg1"/>
                 </a:solidFill>
               </a:rPr>
-              <a:t>Outputs</a:t>
-            </a:r>
-            <a:endParaRPr lang="en-US" sz="1400" dirty="0"/>
+              <a:t>Safety</a:t>
+            </a:r>
+            <a:endParaRPr lang="en-US" sz="1350" dirty="0"/>
           </a:p>
         </p:txBody>
       </p:sp>
@@ -19349,8 +19349,8 @@
         </p:nvSpPr>
         <p:spPr>
           <a:xfrm>
-            <a:off x="2331720" y="5760720"/>
-            <a:ext cx="8778240" cy="457200"/>
+            <a:off x="2331720" y="5440680"/>
+            <a:ext cx="8778240" cy="384048"/>
           </a:xfrm>
           <a:prstGeom prst="rect">
             <a:avLst/>
@@ -19366,14 +19366,113 @@
               <a:buNone/>
             </a:pPr>
             <a:r>
-              <a:rPr lang="en-US" sz="1400" dirty="0">
+              <a:rPr lang="en-US" sz="1350" dirty="0">
                 <a:solidFill>
                   <a:schemeClr val="tx1"/>
                 </a:solidFill>
               </a:rPr>
+              <a:t>uploads run in a restricted container: no capabilities, read-only filesystem, internal network</a:t>
+            </a:r>
+            <a:endParaRPr lang="en-US" sz="1350" dirty="0"/>
+          </a:p>
+        </p:txBody>
+      </p:sp>
+      <p:sp>
+        <p:nvSpPr>
+          <p:cNvPr id="25" name="Shape 20"/>
+          <p:cNvSpPr/>
+          <p:nvPr/>
+        </p:nvSpPr>
+        <p:spPr>
+          <a:xfrm>
+            <a:off x="685800" y="5897880"/>
+            <a:ext cx="1463040" cy="384048"/>
+          </a:xfrm>
+          <a:prstGeom prst="roundRect">
+            <a:avLst>
+              <a:gd name="adj" fmla="val 50000"/>
+            </a:avLst>
+          </a:prstGeom>
+          <a:solidFill>
+            <a:schemeClr val="tx1"/>
+          </a:solidFill>
+          <a:ln w="19050">
+            <a:solidFill>
+              <a:schemeClr val="tx1"/>
+            </a:solidFill>
+            <a:prstDash val="solid"/>
+          </a:ln>
+        </p:spPr>
+      </p:sp>
+      <p:sp>
+        <p:nvSpPr>
+          <p:cNvPr id="26" name="Text 21"/>
+          <p:cNvSpPr txBox="1"/>
+          <p:nvPr/>
+        </p:nvSpPr>
+        <p:spPr>
+          <a:xfrm>
+            <a:off x="868680" y="5897880"/>
+            <a:ext cx="1097280" cy="384048"/>
+          </a:xfrm>
+          <a:prstGeom prst="rect">
+            <a:avLst/>
+          </a:prstGeom>
+          <a:noFill/>
+          <a:ln/>
+        </p:spPr>
+        <p:txBody>
+          <a:bodyPr wrap="square" lIns="0" tIns="0" rIns="0" bIns="0" rtlCol="0" anchor="ctr"/>
+          <a:lstStyle/>
+          <a:p>
+            <a:pPr indent="0" marL="0">
+              <a:buNone/>
+            </a:pPr>
+            <a:r>
+              <a:rPr lang="en-US" sz="1350" dirty="0">
+                <a:solidFill>
+                  <a:schemeClr val="bg1"/>
+                </a:solidFill>
+              </a:rPr>
+              <a:t>Outputs</a:t>
+            </a:r>
+            <a:endParaRPr lang="en-US" sz="1350" dirty="0"/>
+          </a:p>
+        </p:txBody>
+      </p:sp>
+      <p:sp>
+        <p:nvSpPr>
+          <p:cNvPr id="27" name="Text 22"/>
+          <p:cNvSpPr txBox="1"/>
+          <p:nvPr/>
+        </p:nvSpPr>
+        <p:spPr>
+          <a:xfrm>
+            <a:off x="2331720" y="5897880"/>
+            <a:ext cx="8778240" cy="384048"/>
+          </a:xfrm>
+          <a:prstGeom prst="rect">
+            <a:avLst/>
+          </a:prstGeom>
+          <a:noFill/>
+          <a:ln/>
+        </p:spPr>
+        <p:txBody>
+          <a:bodyPr wrap="square" lIns="0" tIns="0" rIns="0" bIns="0" rtlCol="0" anchor="ctr"/>
+          <a:lstStyle/>
+          <a:p>
+            <a:pPr indent="0" marL="0">
+              <a:buNone/>
+            </a:pPr>
+            <a:r>
+              <a:rPr lang="en-US" sz="1350" dirty="0">
+                <a:solidFill>
+                  <a:schemeClr val="tx1"/>
+                </a:solidFill>
+              </a:rPr>
               <a:t>HTML, Markdown and JSON reports; web interface (FastAPI) and command-line tool</a:t>
             </a:r>
-            <a:endParaRPr lang="en-US" sz="1400" dirty="0"/>
+            <a:endParaRPr lang="en-US" sz="1350" dirty="0"/>
           </a:p>
         </p:txBody>
       </p:sp>

</xml_diff>

<commit_message>
spec-oracle demo: 2 of 8 rules exercised, not 3
Co-Authored-By: Claude Opus 5.5 <noreply@anthropic.com>
</commit_message>
<xml_diff>
--- a/Katalyze_Final_Review.pptx
+++ b/Katalyze_Final_Review.pptx
@@ -138,37 +138,37 @@
   <p:extLst>
     <p:ext uri="{521415D9-36F7-43E2-AB2F-B90AF26B5E84}">
       <p14:sectionLst xmlns:p14="http://schemas.microsoft.com/office/powerpoint/2010/main">
-        <p14:section name="Title" id="{41778e0d-bfa5-a53c-91a4-0f5c1ee27029}">
+        <p14:section name="Title" id="{1cc225c0-67f5-177c-e5db-82c4e093c737}">
           <p14:sldIdLst>
             <p14:sldId id="256"/>
           </p14:sldIdLst>
         </p14:section>
-        <p14:section name="Contents" id="{769edef9-fd16-f048-1e32-6c6c4ed266ea}">
+        <p14:section name="Contents" id="{f556172a-322f-c712-3cfc-d6b8d1ab6685}">
           <p14:sldIdLst>
             <p14:sldId id="257"/>
           </p14:sldIdLst>
         </p14:section>
-        <p14:section name="Introduction" id="{68a7d0fa-e26d-063e-bebe-26d466af0fc9}">
+        <p14:section name="Introduction" id="{cf093be2-c3b7-6759-8eef-1215909868d4}">
           <p14:sldIdLst>
             <p14:sldId id="258"/>
           </p14:sldIdLst>
         </p14:section>
-        <p14:section name="Problem statement" id="{cfb85088-631b-180d-f05c-0a937f2acdea}">
+        <p14:section name="Problem statement" id="{da016282-8a37-a31c-5951-5369d210b2cb}">
           <p14:sldIdLst>
             <p14:sldId id="259"/>
           </p14:sldIdLst>
         </p14:section>
-        <p14:section name="Literature review" id="{d5c5b914-8fcf-5778-1e7a-b489272ca991}">
+        <p14:section name="Literature review" id="{eddb1184-8f61-d5ad-c57b-9fa54c352fd7}">
           <p14:sldIdLst>
             <p14:sldId id="260"/>
           </p14:sldIdLst>
         </p14:section>
-        <p14:section name="Research gaps" id="{4ff92728-f4f2-1264-4084-e48e1305c47c}">
+        <p14:section name="Research gaps" id="{169766a3-3262-4fef-4cfc-3cac8bcdfd96}">
           <p14:sldIdLst>
             <p14:sldId id="261"/>
           </p14:sldIdLst>
         </p14:section>
-        <p14:section name="Methodology" id="{1908e5bf-46b6-e1ab-53a4-5b829f99c8bf}">
+        <p14:section name="Methodology" id="{61fd26b2-a880-c4ee-5cf9-f4a6b635f3d6}">
           <p14:sldIdLst>
             <p14:sldId id="262"/>
             <p14:sldId id="263"/>
@@ -180,18 +180,18 @@
             <p14:sldId id="269"/>
           </p14:sldIdLst>
         </p14:section>
-        <p14:section name="Workflow" id="{94295441-a9a1-5b37-e1a3-9dec8b682dda}">
+        <p14:section name="Workflow" id="{7b5d7bf2-420b-517b-6330-fbb46c2f4eb2}">
           <p14:sldIdLst>
             <p14:sldId id="270"/>
           </p14:sldIdLst>
         </p14:section>
-        <p14:section name="Evaluation design" id="{a3bcee42-432c-4a23-4fa8-ccc76edbedd4}">
+        <p14:section name="Evaluation design" id="{86822dd7-b093-ddbd-fde6-119630c3ba5d}">
           <p14:sldIdLst>
             <p14:sldId id="271"/>
             <p14:sldId id="272"/>
           </p14:sldIdLst>
         </p14:section>
-        <p14:section name="Results" id="{92571ed5-a4dd-54eb-0247-8d7d86987071}">
+        <p14:section name="Results" id="{70e195e8-2bdc-a971-07a4-5da836d253fd}">
           <p14:sldIdLst>
             <p14:sldId id="273"/>
             <p14:sldId id="274"/>
@@ -202,33 +202,33 @@
             <p14:sldId id="279"/>
           </p14:sldIdLst>
         </p14:section>
-        <p14:section name="Results analysis" id="{cafbba4a-5afd-6040-2a7c-2b09c053b133}">
+        <p14:section name="Results analysis" id="{a4731bfb-9cd7-09d1-0151-095d33b31932}">
           <p14:sldIdLst>
             <p14:sldId id="280"/>
             <p14:sldId id="281"/>
           </p14:sldIdLst>
         </p14:section>
-        <p14:section name="Our app" id="{dbfed1bd-2e6a-cdf7-32d6-2299251bddd1}">
+        <p14:section name="Our app" id="{1ef794cf-239b-791b-5b3e-eb8e320ce2f2}">
           <p14:sldIdLst>
             <p14:sldId id="282"/>
           </p14:sldIdLst>
         </p14:section>
-        <p14:section name="Conclusion" id="{fa2aeea8-5d73-95cb-0616-8b33fb142eb6}">
+        <p14:section name="Conclusion" id="{493026cf-2b97-f12d-b4d6-0a5f8de88749}">
           <p14:sldIdLst>
             <p14:sldId id="283"/>
           </p14:sldIdLst>
         </p14:section>
-        <p14:section name="Future work" id="{950e5a74-828a-5e64-4c55-86d9ccc9e49d}">
+        <p14:section name="Future work" id="{16042dbe-fc02-a366-4f26-95877826d42a}">
           <p14:sldIdLst>
             <p14:sldId id="284"/>
           </p14:sldIdLst>
         </p14:section>
-        <p14:section name="Team" id="{bfd93d79-4753-986f-4aa4-04bde4977b21}">
+        <p14:section name="Team" id="{9e9e4d01-c113-95b3-a3cc-f1af9b62ca05}">
           <p14:sldIdLst>
             <p14:sldId id="285"/>
           </p14:sldIdLst>
         </p14:section>
-        <p14:section name="References" id="{9fb20d3c-f044-3854-97ea-b0c4dd6d3e57}">
+        <p14:section name="References" id="{c31a7ef1-7ca9-ecd9-6562-c4c973cd1b1d}">
           <p14:sldIdLst>
             <p14:sldId id="286"/>
             <p14:sldId id="287"/>
@@ -18509,7 +18509,7 @@
                   <a:schemeClr val="tx2"/>
                 </a:solidFill>
               </a:rPr>
-              <a:t>10 proposed, 8 kept (2 malformed). Only 3 were exercised in this run: the tester never used the sort control after the rules were written, so the known sorting bug went untested.</a:t>
+              <a:t>10 proposed, 8 kept (2 malformed). Only 2 were exercised in this run: the tester never used the sort control after the rules were written, so the known sorting bug went untested.</a:t>
             </a:r>
             <a:endParaRPr lang="en-US" sz="1250" dirty="0"/>
           </a:p>

</xml_diff>

<commit_message>
final-review deck: drop Katalyze (tuned) from the results and the tuning-faults column
Co-Authored-By: Claude Opus 5.5 <noreply@anthropic.com>
</commit_message>
<xml_diff>
--- a/Katalyze_Final_Review.pptx
+++ b/Katalyze_Final_Review.pptx
@@ -10273,22 +10273,21 @@
         </p:nvGraphicFramePr>
         <p:xfrm>
           <a:off x="1028700" y="3611880"/>
-          <a:ext cx="16230600" cy="4206240"/>
+          <a:ext cx="16230600" cy="3657600"/>
         </p:xfrm>
         <a:graphic>
           <a:graphicData uri="http://schemas.openxmlformats.org/drawingml/2006/table">
             <a:tbl>
               <a:tblPr firstRow="1" bandRow="1"/>
               <a:tblGrid>
-                <a:gridCol w="3337560"/>
-                <a:gridCol w="2148840"/>
-                <a:gridCol w="2240280"/>
-                <a:gridCol w="2057400"/>
-                <a:gridCol w="2194560"/>
-                <a:gridCol w="2057400"/>
-                <a:gridCol w="2194560"/>
+                <a:gridCol w="3703320"/>
+                <a:gridCol w="2514600"/>
+                <a:gridCol w="2606040"/>
+                <a:gridCol w="2423160"/>
+                <a:gridCol w="2514600"/>
+                <a:gridCol w="2468880"/>
               </a:tblGrid>
-              <a:tr h="701040">
+              <a:tr h="731520">
                 <a:tc>
                   <a:txBody>
                     <a:bodyPr/>
@@ -10604,69 +10603,6 @@
                           <a:latin typeface="Arial Bold"/>
                           <a:cs typeface="Arial Bold"/>
                         </a:rPr>
-                        <a:t>Distinct faults</a:t>
-                      </a:r>
-                      <a:endParaRPr lang="en-US" sz="1800" dirty="0"/>
-                    </a:p>
-                    <a:p>
-                      <a:pPr algn="ctr">
-                        <a:buNone/>
-                      </a:pPr>
-                      <a:r>
-                        <a:rPr lang="en-US" sz="1500" dirty="0">
-                          <a:solidFill>
-                            <a:srgbClr val="D9E8DC"/>
-                          </a:solidFill>
-                          <a:latin typeface="Arial"/>
-                          <a:cs typeface="Arial"/>
-                        </a:rPr>
-                        <a:t>tuning, of 41</a:t>
-                      </a:r>
-                      <a:endParaRPr lang="en-US" sz="1500" dirty="0"/>
-                    </a:p>
-                  </a:txBody>
-                  <a:tcPr marL="137160" marR="137160" marT="45720" marB="45720" anchor="ctr">
-                    <a:lnL w="12700">
-                      <a:solidFill>
-                        <a:srgbClr val="D5DCD7"/>
-                      </a:solidFill>
-                    </a:lnL>
-                    <a:lnR w="12700">
-                      <a:solidFill>
-                        <a:srgbClr val="D5DCD7"/>
-                      </a:solidFill>
-                    </a:lnR>
-                    <a:lnT w="12700">
-                      <a:solidFill>
-                        <a:srgbClr val="D5DCD7"/>
-                      </a:solidFill>
-                    </a:lnT>
-                    <a:lnB w="12700">
-                      <a:solidFill>
-                        <a:srgbClr val="D5DCD7"/>
-                      </a:solidFill>
-                    </a:lnB>
-                    <a:solidFill>
-                      <a:srgbClr val="00461A"/>
-                    </a:solidFill>
-                  </a:tcPr>
-                </a:tc>
-                <a:tc>
-                  <a:txBody>
-                    <a:bodyPr/>
-                    <a:lstStyle/>
-                    <a:p>
-                      <a:pPr algn="ctr">
-                        <a:buNone/>
-                      </a:pPr>
-                      <a:r>
-                        <a:rPr lang="en-US" sz="1800" b="1" dirty="0">
-                          <a:solidFill>
-                            <a:srgbClr val="FFFFFF"/>
-                          </a:solidFill>
-                          <a:latin typeface="Arial Bold"/>
-                          <a:cs typeface="Arial Bold"/>
-                        </a:rPr>
                         <a:t>Errors per run</a:t>
                       </a:r>
                       <a:endParaRPr lang="en-US" sz="1800" dirty="0"/>
@@ -10715,7 +10651,7 @@
                   </a:tcPr>
                 </a:tc>
               </a:tr>
-              <a:tr h="701040">
+              <a:tr h="731520">
                 <a:tc>
                   <a:txBody>
                     <a:bodyPr/>
@@ -10967,53 +10903,6 @@
                           <a:latin typeface="Arial"/>
                           <a:cs typeface="Arial"/>
                         </a:rPr>
-                        <a:t>19</a:t>
-                      </a:r>
-                      <a:endParaRPr lang="en-US" sz="1900" dirty="0"/>
-                    </a:p>
-                  </a:txBody>
-                  <a:tcPr marL="137160" marR="137160" marT="45720" marB="45720" anchor="ctr">
-                    <a:lnL w="12700">
-                      <a:solidFill>
-                        <a:srgbClr val="D5DCD7"/>
-                      </a:solidFill>
-                    </a:lnL>
-                    <a:lnR w="12700">
-                      <a:solidFill>
-                        <a:srgbClr val="D5DCD7"/>
-                      </a:solidFill>
-                    </a:lnR>
-                    <a:lnT w="12700">
-                      <a:solidFill>
-                        <a:srgbClr val="D5DCD7"/>
-                      </a:solidFill>
-                    </a:lnT>
-                    <a:lnB w="12700">
-                      <a:solidFill>
-                        <a:srgbClr val="D5DCD7"/>
-                      </a:solidFill>
-                    </a:lnB>
-                    <a:solidFill>
-                      <a:srgbClr val="FFFFFF"/>
-                    </a:solidFill>
-                  </a:tcPr>
-                </a:tc>
-                <a:tc>
-                  <a:txBody>
-                    <a:bodyPr/>
-                    <a:lstStyle/>
-                    <a:p>
-                      <a:pPr algn="ctr">
-                        <a:buNone/>
-                      </a:pPr>
-                      <a:r>
-                        <a:rPr lang="en-US" sz="1900" dirty="0">
-                          <a:solidFill>
-                            <a:srgbClr val="111111"/>
-                          </a:solidFill>
-                          <a:latin typeface="Arial"/>
-                          <a:cs typeface="Arial"/>
-                        </a:rPr>
                         <a:t>5.38</a:t>
                       </a:r>
                       <a:endParaRPr lang="en-US" sz="1900" dirty="0"/>
@@ -11046,7 +10935,7 @@
                   </a:tcPr>
                 </a:tc>
               </a:tr>
-              <a:tr h="701040">
+              <a:tr h="731520">
                 <a:tc>
                   <a:txBody>
                     <a:bodyPr/>
@@ -11150,12 +11039,12 @@
                         <a:buNone/>
                       </a:pPr>
                       <a:r>
-                        <a:rPr lang="en-US" sz="1900" dirty="0">
+                        <a:rPr lang="en-US" sz="1900" b="1" dirty="0">
                           <a:solidFill>
-                            <a:srgbClr val="111111"/>
+                            <a:srgbClr val="00461A"/>
                           </a:solidFill>
-                          <a:latin typeface="Arial"/>
-                          <a:cs typeface="Arial"/>
+                          <a:latin typeface="Arial Bold"/>
+                          <a:cs typeface="Arial Bold"/>
                         </a:rPr>
                         <a:t>737</a:t>
                       </a:r>
@@ -11298,53 +11187,6 @@
                           <a:latin typeface="Arial"/>
                           <a:cs typeface="Arial"/>
                         </a:rPr>
-                        <a:t>19</a:t>
-                      </a:r>
-                      <a:endParaRPr lang="en-US" sz="1900" dirty="0"/>
-                    </a:p>
-                  </a:txBody>
-                  <a:tcPr marL="137160" marR="137160" marT="45720" marB="45720" anchor="ctr">
-                    <a:lnL w="12700">
-                      <a:solidFill>
-                        <a:srgbClr val="D5DCD7"/>
-                      </a:solidFill>
-                    </a:lnL>
-                    <a:lnR w="12700">
-                      <a:solidFill>
-                        <a:srgbClr val="D5DCD7"/>
-                      </a:solidFill>
-                    </a:lnR>
-                    <a:lnT w="12700">
-                      <a:solidFill>
-                        <a:srgbClr val="D5DCD7"/>
-                      </a:solidFill>
-                    </a:lnT>
-                    <a:lnB w="12700">
-                      <a:solidFill>
-                        <a:srgbClr val="D5DCD7"/>
-                      </a:solidFill>
-                    </a:lnB>
-                    <a:solidFill>
-                      <a:srgbClr val="E9EEEA"/>
-                    </a:solidFill>
-                  </a:tcPr>
-                </a:tc>
-                <a:tc>
-                  <a:txBody>
-                    <a:bodyPr/>
-                    <a:lstStyle/>
-                    <a:p>
-                      <a:pPr algn="ctr">
-                        <a:buNone/>
-                      </a:pPr>
-                      <a:r>
-                        <a:rPr lang="en-US" sz="1900" dirty="0">
-                          <a:solidFill>
-                            <a:srgbClr val="111111"/>
-                          </a:solidFill>
-                          <a:latin typeface="Arial"/>
-                          <a:cs typeface="Arial"/>
-                        </a:rPr>
                         <a:t>2.88</a:t>
                       </a:r>
                       <a:endParaRPr lang="en-US" sz="1900" dirty="0"/>
@@ -11377,7 +11219,7 @@
                   </a:tcPr>
                 </a:tc>
               </a:tr>
-              <a:tr h="701040">
+              <a:tr h="731520">
                 <a:tc>
                   <a:txBody>
                     <a:bodyPr/>
@@ -11629,53 +11471,6 @@
                           <a:latin typeface="Arial"/>
                           <a:cs typeface="Arial"/>
                         </a:rPr>
-                        <a:t>16</a:t>
-                      </a:r>
-                      <a:endParaRPr lang="en-US" sz="1900" dirty="0"/>
-                    </a:p>
-                  </a:txBody>
-                  <a:tcPr marL="137160" marR="137160" marT="45720" marB="45720" anchor="ctr">
-                    <a:lnL w="12700">
-                      <a:solidFill>
-                        <a:srgbClr val="D5DCD7"/>
-                      </a:solidFill>
-                    </a:lnL>
-                    <a:lnR w="12700">
-                      <a:solidFill>
-                        <a:srgbClr val="D5DCD7"/>
-                      </a:solidFill>
-                    </a:lnR>
-                    <a:lnT w="12700">
-                      <a:solidFill>
-                        <a:srgbClr val="D5DCD7"/>
-                      </a:solidFill>
-                    </a:lnT>
-                    <a:lnB w="12700">
-                      <a:solidFill>
-                        <a:srgbClr val="D5DCD7"/>
-                      </a:solidFill>
-                    </a:lnB>
-                    <a:solidFill>
-                      <a:srgbClr val="FFFFFF"/>
-                    </a:solidFill>
-                  </a:tcPr>
-                </a:tc>
-                <a:tc>
-                  <a:txBody>
-                    <a:bodyPr/>
-                    <a:lstStyle/>
-                    <a:p>
-                      <a:pPr algn="ctr">
-                        <a:buNone/>
-                      </a:pPr>
-                      <a:r>
-                        <a:rPr lang="en-US" sz="1900" dirty="0">
-                          <a:solidFill>
-                            <a:srgbClr val="111111"/>
-                          </a:solidFill>
-                          <a:latin typeface="Arial"/>
-                          <a:cs typeface="Arial"/>
-                        </a:rPr>
                         <a:t>2.83</a:t>
                       </a:r>
                       <a:endParaRPr lang="en-US" sz="1900" dirty="0"/>
@@ -11708,7 +11503,7 @@
                   </a:tcPr>
                 </a:tc>
               </a:tr>
-              <a:tr h="701040">
+              <a:tr h="731520">
                 <a:tc>
                   <a:txBody>
                     <a:bodyPr/>
@@ -11953,53 +11748,6 @@
                         <a:buNone/>
                       </a:pPr>
                       <a:r>
-                        <a:rPr lang="en-US" sz="1900" dirty="0">
-                          <a:solidFill>
-                            <a:srgbClr val="111111"/>
-                          </a:solidFill>
-                          <a:latin typeface="Arial"/>
-                          <a:cs typeface="Arial"/>
-                        </a:rPr>
-                        <a:t>16</a:t>
-                      </a:r>
-                      <a:endParaRPr lang="en-US" sz="1900" dirty="0"/>
-                    </a:p>
-                  </a:txBody>
-                  <a:tcPr marL="137160" marR="137160" marT="45720" marB="45720" anchor="ctr">
-                    <a:lnL w="12700">
-                      <a:solidFill>
-                        <a:srgbClr val="D5DCD7"/>
-                      </a:solidFill>
-                    </a:lnL>
-                    <a:lnR w="12700">
-                      <a:solidFill>
-                        <a:srgbClr val="D5DCD7"/>
-                      </a:solidFill>
-                    </a:lnR>
-                    <a:lnT w="12700">
-                      <a:solidFill>
-                        <a:srgbClr val="D5DCD7"/>
-                      </a:solidFill>
-                    </a:lnT>
-                    <a:lnB w="12700">
-                      <a:solidFill>
-                        <a:srgbClr val="D5DCD7"/>
-                      </a:solidFill>
-                    </a:lnB>
-                    <a:solidFill>
-                      <a:srgbClr val="E9EEEA"/>
-                    </a:solidFill>
-                  </a:tcPr>
-                </a:tc>
-                <a:tc>
-                  <a:txBody>
-                    <a:bodyPr/>
-                    <a:lstStyle/>
-                    <a:p>
-                      <a:pPr algn="ctr">
-                        <a:buNone/>
-                      </a:pPr>
-                      <a:r>
                         <a:rPr lang="en-US" sz="1900" b="1" dirty="0">
                           <a:solidFill>
                             <a:srgbClr val="00461A"/>
@@ -12039,337 +11787,6 @@
                   </a:tcPr>
                 </a:tc>
               </a:tr>
-              <a:tr h="701040">
-                <a:tc>
-                  <a:txBody>
-                    <a:bodyPr/>
-                    <a:lstStyle/>
-                    <a:p>
-                      <a:pPr algn="l">
-                        <a:buNone/>
-                      </a:pPr>
-                      <a:r>
-                        <a:rPr lang="en-US" sz="1900" b="1" dirty="0">
-                          <a:solidFill>
-                            <a:srgbClr val="111111"/>
-                          </a:solidFill>
-                          <a:latin typeface="Arial Bold"/>
-                          <a:cs typeface="Arial Bold"/>
-                        </a:rPr>
-                        <a:t>Katalyze, tuned</a:t>
-                      </a:r>
-                      <a:endParaRPr lang="en-US" sz="1900" dirty="0"/>
-                    </a:p>
-                  </a:txBody>
-                  <a:tcPr marL="137160" marR="137160" marT="45720" marB="45720" anchor="ctr">
-                    <a:lnL w="12700">
-                      <a:solidFill>
-                        <a:srgbClr val="D5DCD7"/>
-                      </a:solidFill>
-                    </a:lnL>
-                    <a:lnR w="12700">
-                      <a:solidFill>
-                        <a:srgbClr val="D5DCD7"/>
-                      </a:solidFill>
-                    </a:lnR>
-                    <a:lnT w="12700">
-                      <a:solidFill>
-                        <a:srgbClr val="D5DCD7"/>
-                      </a:solidFill>
-                    </a:lnT>
-                    <a:lnB w="12700">
-                      <a:solidFill>
-                        <a:srgbClr val="D5DCD7"/>
-                      </a:solidFill>
-                    </a:lnB>
-                    <a:solidFill>
-                      <a:srgbClr val="FFFFFF"/>
-                    </a:solidFill>
-                  </a:tcPr>
-                </a:tc>
-                <a:tc>
-                  <a:txBody>
-                    <a:bodyPr/>
-                    <a:lstStyle/>
-                    <a:p>
-                      <a:pPr algn="ctr">
-                        <a:buNone/>
-                      </a:pPr>
-                      <a:r>
-                        <a:rPr lang="en-US" sz="1900" dirty="0">
-                          <a:solidFill>
-                            <a:srgbClr val="555555"/>
-                          </a:solidFill>
-                          <a:latin typeface="Arial"/>
-                          <a:cs typeface="Arial"/>
-                        </a:rPr>
-                        <a:t>–</a:t>
-                      </a:r>
-                      <a:endParaRPr lang="en-US" sz="1900" dirty="0"/>
-                    </a:p>
-                  </a:txBody>
-                  <a:tcPr marL="137160" marR="137160" marT="45720" marB="45720" anchor="ctr">
-                    <a:lnL w="12700">
-                      <a:solidFill>
-                        <a:srgbClr val="D5DCD7"/>
-                      </a:solidFill>
-                    </a:lnL>
-                    <a:lnR w="12700">
-                      <a:solidFill>
-                        <a:srgbClr val="D5DCD7"/>
-                      </a:solidFill>
-                    </a:lnR>
-                    <a:lnT w="12700">
-                      <a:solidFill>
-                        <a:srgbClr val="D5DCD7"/>
-                      </a:solidFill>
-                    </a:lnT>
-                    <a:lnB w="12700">
-                      <a:solidFill>
-                        <a:srgbClr val="D5DCD7"/>
-                      </a:solidFill>
-                    </a:lnB>
-                    <a:solidFill>
-                      <a:srgbClr val="FFFFFF"/>
-                    </a:solidFill>
-                  </a:tcPr>
-                </a:tc>
-                <a:tc>
-                  <a:txBody>
-                    <a:bodyPr/>
-                    <a:lstStyle/>
-                    <a:p>
-                      <a:pPr algn="ctr">
-                        <a:buNone/>
-                      </a:pPr>
-                      <a:r>
-                        <a:rPr lang="en-US" sz="1900" dirty="0">
-                          <a:solidFill>
-                            <a:srgbClr val="555555"/>
-                          </a:solidFill>
-                          <a:latin typeface="Arial"/>
-                          <a:cs typeface="Arial"/>
-                        </a:rPr>
-                        <a:t>–</a:t>
-                      </a:r>
-                      <a:endParaRPr lang="en-US" sz="1900" dirty="0"/>
-                    </a:p>
-                  </a:txBody>
-                  <a:tcPr marL="137160" marR="137160" marT="45720" marB="45720" anchor="ctr">
-                    <a:lnL w="12700">
-                      <a:solidFill>
-                        <a:srgbClr val="D5DCD7"/>
-                      </a:solidFill>
-                    </a:lnL>
-                    <a:lnR w="12700">
-                      <a:solidFill>
-                        <a:srgbClr val="D5DCD7"/>
-                      </a:solidFill>
-                    </a:lnR>
-                    <a:lnT w="12700">
-                      <a:solidFill>
-                        <a:srgbClr val="D5DCD7"/>
-                      </a:solidFill>
-                    </a:lnT>
-                    <a:lnB w="12700">
-                      <a:solidFill>
-                        <a:srgbClr val="D5DCD7"/>
-                      </a:solidFill>
-                    </a:lnB>
-                    <a:solidFill>
-                      <a:srgbClr val="FFFFFF"/>
-                    </a:solidFill>
-                  </a:tcPr>
-                </a:tc>
-                <a:tc>
-                  <a:txBody>
-                    <a:bodyPr/>
-                    <a:lstStyle/>
-                    <a:p>
-                      <a:pPr algn="ctr">
-                        <a:buNone/>
-                      </a:pPr>
-                      <a:r>
-                        <a:rPr lang="en-US" sz="1900" dirty="0">
-                          <a:solidFill>
-                            <a:srgbClr val="555555"/>
-                          </a:solidFill>
-                          <a:latin typeface="Arial"/>
-                          <a:cs typeface="Arial"/>
-                        </a:rPr>
-                        <a:t>–</a:t>
-                      </a:r>
-                      <a:endParaRPr lang="en-US" sz="1900" dirty="0"/>
-                    </a:p>
-                  </a:txBody>
-                  <a:tcPr marL="137160" marR="137160" marT="45720" marB="45720" anchor="ctr">
-                    <a:lnL w="12700">
-                      <a:solidFill>
-                        <a:srgbClr val="D5DCD7"/>
-                      </a:solidFill>
-                    </a:lnL>
-                    <a:lnR w="12700">
-                      <a:solidFill>
-                        <a:srgbClr val="D5DCD7"/>
-                      </a:solidFill>
-                    </a:lnR>
-                    <a:lnT w="12700">
-                      <a:solidFill>
-                        <a:srgbClr val="D5DCD7"/>
-                      </a:solidFill>
-                    </a:lnT>
-                    <a:lnB w="12700">
-                      <a:solidFill>
-                        <a:srgbClr val="D5DCD7"/>
-                      </a:solidFill>
-                    </a:lnB>
-                    <a:solidFill>
-                      <a:srgbClr val="FFFFFF"/>
-                    </a:solidFill>
-                  </a:tcPr>
-                </a:tc>
-                <a:tc>
-                  <a:txBody>
-                    <a:bodyPr/>
-                    <a:lstStyle/>
-                    <a:p>
-                      <a:pPr algn="ctr">
-                        <a:buNone/>
-                      </a:pPr>
-                      <a:r>
-                        <a:rPr lang="en-US" sz="1900" dirty="0">
-                          <a:solidFill>
-                            <a:srgbClr val="555555"/>
-                          </a:solidFill>
-                          <a:latin typeface="Arial"/>
-                          <a:cs typeface="Arial"/>
-                        </a:rPr>
-                        <a:t>–</a:t>
-                      </a:r>
-                      <a:endParaRPr lang="en-US" sz="1900" dirty="0"/>
-                    </a:p>
-                  </a:txBody>
-                  <a:tcPr marL="137160" marR="137160" marT="45720" marB="45720" anchor="ctr">
-                    <a:lnL w="12700">
-                      <a:solidFill>
-                        <a:srgbClr val="D5DCD7"/>
-                      </a:solidFill>
-                    </a:lnL>
-                    <a:lnR w="12700">
-                      <a:solidFill>
-                        <a:srgbClr val="D5DCD7"/>
-                      </a:solidFill>
-                    </a:lnR>
-                    <a:lnT w="12700">
-                      <a:solidFill>
-                        <a:srgbClr val="D5DCD7"/>
-                      </a:solidFill>
-                    </a:lnT>
-                    <a:lnB w="12700">
-                      <a:solidFill>
-                        <a:srgbClr val="D5DCD7"/>
-                      </a:solidFill>
-                    </a:lnB>
-                    <a:solidFill>
-                      <a:srgbClr val="FFFFFF"/>
-                    </a:solidFill>
-                  </a:tcPr>
-                </a:tc>
-                <a:tc>
-                  <a:txBody>
-                    <a:bodyPr/>
-                    <a:lstStyle/>
-                    <a:p>
-                      <a:pPr algn="ctr">
-                        <a:buNone/>
-                      </a:pPr>
-                      <a:r>
-                        <a:rPr lang="en-US" sz="1900" b="1" dirty="0">
-                          <a:solidFill>
-                            <a:srgbClr val="00461A"/>
-                          </a:solidFill>
-                          <a:latin typeface="Arial Bold"/>
-                          <a:cs typeface="Arial Bold"/>
-                        </a:rPr>
-                        <a:t>22</a:t>
-                      </a:r>
-                      <a:endParaRPr lang="en-US" sz="1900" dirty="0"/>
-                    </a:p>
-                  </a:txBody>
-                  <a:tcPr marL="137160" marR="137160" marT="45720" marB="45720" anchor="ctr">
-                    <a:lnL w="12700">
-                      <a:solidFill>
-                        <a:srgbClr val="D5DCD7"/>
-                      </a:solidFill>
-                    </a:lnL>
-                    <a:lnR w="12700">
-                      <a:solidFill>
-                        <a:srgbClr val="D5DCD7"/>
-                      </a:solidFill>
-                    </a:lnR>
-                    <a:lnT w="12700">
-                      <a:solidFill>
-                        <a:srgbClr val="D5DCD7"/>
-                      </a:solidFill>
-                    </a:lnT>
-                    <a:lnB w="12700">
-                      <a:solidFill>
-                        <a:srgbClr val="D5DCD7"/>
-                      </a:solidFill>
-                    </a:lnB>
-                    <a:solidFill>
-                      <a:srgbClr val="FFFFFF"/>
-                    </a:solidFill>
-                  </a:tcPr>
-                </a:tc>
-                <a:tc>
-                  <a:txBody>
-                    <a:bodyPr/>
-                    <a:lstStyle/>
-                    <a:p>
-                      <a:pPr algn="ctr">
-                        <a:buNone/>
-                      </a:pPr>
-                      <a:r>
-                        <a:rPr lang="en-US" sz="1900" dirty="0">
-                          <a:solidFill>
-                            <a:srgbClr val="111111"/>
-                          </a:solidFill>
-                          <a:latin typeface="Arial"/>
-                          <a:cs typeface="Arial"/>
-                        </a:rPr>
-                        <a:t>3.12</a:t>
-                      </a:r>
-                      <a:endParaRPr lang="en-US" sz="1900" dirty="0"/>
-                    </a:p>
-                  </a:txBody>
-                  <a:tcPr marL="137160" marR="137160" marT="45720" marB="45720" anchor="ctr">
-                    <a:lnL w="12700">
-                      <a:solidFill>
-                        <a:srgbClr val="D5DCD7"/>
-                      </a:solidFill>
-                    </a:lnL>
-                    <a:lnR w="12700">
-                      <a:solidFill>
-                        <a:srgbClr val="D5DCD7"/>
-                      </a:solidFill>
-                    </a:lnR>
-                    <a:lnT w="12700">
-                      <a:solidFill>
-                        <a:srgbClr val="D5DCD7"/>
-                      </a:solidFill>
-                    </a:lnT>
-                    <a:lnB w="12700">
-                      <a:solidFill>
-                        <a:srgbClr val="D5DCD7"/>
-                      </a:solidFill>
-                    </a:lnB>
-                    <a:solidFill>
-                      <a:srgbClr val="FFFFFF"/>
-                    </a:solidFill>
-                  </a:tcPr>
-                </a:tc>
-              </a:tr>
             </a:tbl>
           </a:graphicData>
         </a:graphic>
@@ -12382,8 +11799,8 @@
         </p:nvSpPr>
         <p:spPr>
           <a:xfrm>
-            <a:off x="1028700" y="8092440"/>
-            <a:ext cx="7863840" cy="1600200"/>
+            <a:off x="1028700" y="7863840"/>
+            <a:ext cx="7863840" cy="1737360"/>
           </a:xfrm>
           <a:prstGeom prst="roundRect">
             <a:avLst>
@@ -12480,8 +11897,8 @@
         </p:nvSpPr>
         <p:spPr>
           <a:xfrm>
-            <a:off x="9258300" y="8183880"/>
-            <a:ext cx="8001000" cy="1508760"/>
+            <a:off x="9258300" y="7955280"/>
+            <a:ext cx="8001000" cy="1737360"/>
           </a:xfrm>
           <a:prstGeom prst="rect">
             <a:avLst/>
@@ -12514,7 +11931,7 @@
                 <a:latin typeface="Arial"/>
                 <a:cs typeface="Arial"/>
               </a:rPr>
-              <a:t>RMST: restricted mean time to the first verified fault, in browser interactions (budget 2,000). Bold: best in the column. –: not run in that evaluation.</a:t>
+              <a:t>RMST: restricted mean time to the first verified fault, in browser interactions (budget 2,000). Bold: best in the column. –: curiosity RL was added after the held-out evaluation, which was frozen and run once.</a:t>
             </a:r>
             <a:endParaRPr lang="en-US" sz="1500" dirty="0"/>
           </a:p>
@@ -25634,12 +25051,11 @@
             <a:tbl>
               <a:tblPr firstRow="1" bandRow="1"/>
               <a:tblGrid>
-                <a:gridCol w="4069080"/>
-                <a:gridCol w="2377440"/>
-                <a:gridCol w="2377440"/>
-                <a:gridCol w="2651760"/>
-                <a:gridCol w="2377440"/>
-                <a:gridCol w="2377440"/>
+                <a:gridCol w="4526280"/>
+                <a:gridCol w="2926080"/>
+                <a:gridCol w="3291840"/>
+                <a:gridCol w="2743200"/>
+                <a:gridCol w="2743200"/>
               </a:tblGrid>
               <a:tr h="525780">
                 <a:tc>
@@ -25659,53 +25075,6 @@
                           <a:cs typeface="Arial Bold"/>
                         </a:rPr>
                         <a:t>Application</a:t>
-                      </a:r>
-                      <a:endParaRPr lang="en-US" sz="1800" dirty="0"/>
-                    </a:p>
-                  </a:txBody>
-                  <a:tcPr marL="137160" marR="137160" marT="45720" marB="45720" anchor="ctr">
-                    <a:lnL w="12700">
-                      <a:solidFill>
-                        <a:srgbClr val="D5DCD7"/>
-                      </a:solidFill>
-                    </a:lnL>
-                    <a:lnR w="12700">
-                      <a:solidFill>
-                        <a:srgbClr val="D5DCD7"/>
-                      </a:solidFill>
-                    </a:lnR>
-                    <a:lnT w="12700">
-                      <a:solidFill>
-                        <a:srgbClr val="D5DCD7"/>
-                      </a:solidFill>
-                    </a:lnT>
-                    <a:lnB w="12700">
-                      <a:solidFill>
-                        <a:srgbClr val="D5DCD7"/>
-                      </a:solidFill>
-                    </a:lnB>
-                    <a:solidFill>
-                      <a:srgbClr val="00461A"/>
-                    </a:solidFill>
-                  </a:tcPr>
-                </a:tc>
-                <a:tc>
-                  <a:txBody>
-                    <a:bodyPr/>
-                    <a:lstStyle/>
-                    <a:p>
-                      <a:pPr algn="ctr">
-                        <a:buNone/>
-                      </a:pPr>
-                      <a:r>
-                        <a:rPr lang="en-US" sz="1800" b="1" dirty="0">
-                          <a:solidFill>
-                            <a:srgbClr val="FFFFFF"/>
-                          </a:solidFill>
-                          <a:latin typeface="Arial Bold"/>
-                          <a:cs typeface="Arial Bold"/>
-                        </a:rPr>
-                        <a:t>Katalyze, tuned</a:t>
                       </a:r>
                       <a:endParaRPr lang="en-US" sz="1800" dirty="0"/>
                     </a:p>
@@ -26014,53 +25383,6 @@
                         <a:buNone/>
                       </a:pPr>
                       <a:r>
-                        <a:rPr lang="en-US" sz="1900" dirty="0">
-                          <a:solidFill>
-                            <a:srgbClr val="111111"/>
-                          </a:solidFill>
-                          <a:latin typeface="Arial"/>
-                          <a:cs typeface="Arial"/>
-                        </a:rPr>
-                        <a:t>48.6</a:t>
-                      </a:r>
-                      <a:endParaRPr lang="en-US" sz="1900" dirty="0"/>
-                    </a:p>
-                  </a:txBody>
-                  <a:tcPr marL="137160" marR="137160" marT="45720" marB="45720" anchor="ctr">
-                    <a:lnL w="12700">
-                      <a:solidFill>
-                        <a:srgbClr val="D5DCD7"/>
-                      </a:solidFill>
-                    </a:lnL>
-                    <a:lnR w="12700">
-                      <a:solidFill>
-                        <a:srgbClr val="D5DCD7"/>
-                      </a:solidFill>
-                    </a:lnR>
-                    <a:lnT w="12700">
-                      <a:solidFill>
-                        <a:srgbClr val="D5DCD7"/>
-                      </a:solidFill>
-                    </a:lnT>
-                    <a:lnB w="12700">
-                      <a:solidFill>
-                        <a:srgbClr val="D5DCD7"/>
-                      </a:solidFill>
-                    </a:lnB>
-                    <a:solidFill>
-                      <a:srgbClr val="FFFFFF"/>
-                    </a:solidFill>
-                  </a:tcPr>
-                </a:tc>
-                <a:tc>
-                  <a:txBody>
-                    <a:bodyPr/>
-                    <a:lstStyle/>
-                    <a:p>
-                      <a:pPr algn="ctr">
-                        <a:buNone/>
-                      </a:pPr>
-                      <a:r>
                         <a:rPr lang="en-US" sz="1900" b="1" dirty="0">
                           <a:solidFill>
                             <a:srgbClr val="00461A"/>
@@ -26259,53 +25581,6 @@
                           <a:cs typeface="Arial Bold"/>
                         </a:rPr>
                         <a:t>Pagekit</a:t>
-                      </a:r>
-                      <a:endParaRPr lang="en-US" sz="1900" dirty="0"/>
-                    </a:p>
-                  </a:txBody>
-                  <a:tcPr marL="137160" marR="137160" marT="45720" marB="45720" anchor="ctr">
-                    <a:lnL w="12700">
-                      <a:solidFill>
-                        <a:srgbClr val="D5DCD7"/>
-                      </a:solidFill>
-                    </a:lnL>
-                    <a:lnR w="12700">
-                      <a:solidFill>
-                        <a:srgbClr val="D5DCD7"/>
-                      </a:solidFill>
-                    </a:lnR>
-                    <a:lnT w="12700">
-                      <a:solidFill>
-                        <a:srgbClr val="D5DCD7"/>
-                      </a:solidFill>
-                    </a:lnT>
-                    <a:lnB w="12700">
-                      <a:solidFill>
-                        <a:srgbClr val="D5DCD7"/>
-                      </a:solidFill>
-                    </a:lnB>
-                    <a:solidFill>
-                      <a:srgbClr val="E9EEEA"/>
-                    </a:solidFill>
-                  </a:tcPr>
-                </a:tc>
-                <a:tc>
-                  <a:txBody>
-                    <a:bodyPr/>
-                    <a:lstStyle/>
-                    <a:p>
-                      <a:pPr algn="ctr">
-                        <a:buNone/>
-                      </a:pPr>
-                      <a:r>
-                        <a:rPr lang="en-US" sz="1900" dirty="0">
-                          <a:solidFill>
-                            <a:srgbClr val="111111"/>
-                          </a:solidFill>
-                          <a:latin typeface="Arial"/>
-                          <a:cs typeface="Arial"/>
-                        </a:rPr>
-                        <a:t>35.0</a:t>
                       </a:r>
                       <a:endParaRPr lang="en-US" sz="1900" dirty="0"/>
                     </a:p>
@@ -26589,53 +25864,6 @@
                           <a:latin typeface="Arial"/>
                           <a:cs typeface="Arial"/>
                         </a:rPr>
-                        <a:t>37.7</a:t>
-                      </a:r>
-                      <a:endParaRPr lang="en-US" sz="1900" dirty="0"/>
-                    </a:p>
-                  </a:txBody>
-                  <a:tcPr marL="137160" marR="137160" marT="45720" marB="45720" anchor="ctr">
-                    <a:lnL w="12700">
-                      <a:solidFill>
-                        <a:srgbClr val="D5DCD7"/>
-                      </a:solidFill>
-                    </a:lnL>
-                    <a:lnR w="12700">
-                      <a:solidFill>
-                        <a:srgbClr val="D5DCD7"/>
-                      </a:solidFill>
-                    </a:lnR>
-                    <a:lnT w="12700">
-                      <a:solidFill>
-                        <a:srgbClr val="D5DCD7"/>
-                      </a:solidFill>
-                    </a:lnT>
-                    <a:lnB w="12700">
-                      <a:solidFill>
-                        <a:srgbClr val="D5DCD7"/>
-                      </a:solidFill>
-                    </a:lnB>
-                    <a:solidFill>
-                      <a:srgbClr val="FFFFFF"/>
-                    </a:solidFill>
-                  </a:tcPr>
-                </a:tc>
-                <a:tc>
-                  <a:txBody>
-                    <a:bodyPr/>
-                    <a:lstStyle/>
-                    <a:p>
-                      <a:pPr algn="ctr">
-                        <a:buNone/>
-                      </a:pPr>
-                      <a:r>
-                        <a:rPr lang="en-US" sz="1900" dirty="0">
-                          <a:solidFill>
-                            <a:srgbClr val="111111"/>
-                          </a:solidFill>
-                          <a:latin typeface="Arial"/>
-                          <a:cs typeface="Arial"/>
-                        </a:rPr>
                         <a:t>34.8</a:t>
                       </a:r>
                       <a:endParaRPr lang="en-US" sz="1900" dirty="0"/>
@@ -26827,53 +26055,6 @@
                           <a:cs typeface="Arial Bold"/>
                         </a:rPr>
                         <a:t>Phoenix</a:t>
-                      </a:r>
-                      <a:endParaRPr lang="en-US" sz="1900" dirty="0"/>
-                    </a:p>
-                  </a:txBody>
-                  <a:tcPr marL="137160" marR="137160" marT="45720" marB="45720" anchor="ctr">
-                    <a:lnL w="12700">
-                      <a:solidFill>
-                        <a:srgbClr val="D5DCD7"/>
-                      </a:solidFill>
-                    </a:lnL>
-                    <a:lnR w="12700">
-                      <a:solidFill>
-                        <a:srgbClr val="D5DCD7"/>
-                      </a:solidFill>
-                    </a:lnR>
-                    <a:lnT w="12700">
-                      <a:solidFill>
-                        <a:srgbClr val="D5DCD7"/>
-                      </a:solidFill>
-                    </a:lnT>
-                    <a:lnB w="12700">
-                      <a:solidFill>
-                        <a:srgbClr val="D5DCD7"/>
-                      </a:solidFill>
-                    </a:lnB>
-                    <a:solidFill>
-                      <a:srgbClr val="E9EEEA"/>
-                    </a:solidFill>
-                  </a:tcPr>
-                </a:tc>
-                <a:tc>
-                  <a:txBody>
-                    <a:bodyPr/>
-                    <a:lstStyle/>
-                    <a:p>
-                      <a:pPr algn="ctr">
-                        <a:buNone/>
-                      </a:pPr>
-                      <a:r>
-                        <a:rPr lang="en-US" sz="1900" dirty="0">
-                          <a:solidFill>
-                            <a:srgbClr val="111111"/>
-                          </a:solidFill>
-                          <a:latin typeface="Arial"/>
-                          <a:cs typeface="Arial"/>
-                        </a:rPr>
-                        <a:t>82.4</a:t>
                       </a:r>
                       <a:endParaRPr lang="en-US" sz="1900" dirty="0"/>
                     </a:p>
@@ -27150,53 +26331,6 @@
                         <a:buNone/>
                       </a:pPr>
                       <a:r>
-                        <a:rPr lang="en-US" sz="1900" b="1" dirty="0">
-                          <a:solidFill>
-                            <a:srgbClr val="00461A"/>
-                          </a:solidFill>
-                          <a:latin typeface="Arial Bold"/>
-                          <a:cs typeface="Arial Bold"/>
-                        </a:rPr>
-                        <a:t>54.0</a:t>
-                      </a:r>
-                      <a:endParaRPr lang="en-US" sz="1900" dirty="0"/>
-                    </a:p>
-                  </a:txBody>
-                  <a:tcPr marL="137160" marR="137160" marT="45720" marB="45720" anchor="ctr">
-                    <a:lnL w="12700">
-                      <a:solidFill>
-                        <a:srgbClr val="D5DCD7"/>
-                      </a:solidFill>
-                    </a:lnL>
-                    <a:lnR w="12700">
-                      <a:solidFill>
-                        <a:srgbClr val="D5DCD7"/>
-                      </a:solidFill>
-                    </a:lnR>
-                    <a:lnT w="12700">
-                      <a:solidFill>
-                        <a:srgbClr val="D5DCD7"/>
-                      </a:solidFill>
-                    </a:lnT>
-                    <a:lnB w="12700">
-                      <a:solidFill>
-                        <a:srgbClr val="D5DCD7"/>
-                      </a:solidFill>
-                    </a:lnB>
-                    <a:solidFill>
-                      <a:srgbClr val="FFFFFF"/>
-                    </a:solidFill>
-                  </a:tcPr>
-                </a:tc>
-                <a:tc>
-                  <a:txBody>
-                    <a:bodyPr/>
-                    <a:lstStyle/>
-                    <a:p>
-                      <a:pPr algn="ctr">
-                        <a:buNone/>
-                      </a:pPr>
-                      <a:r>
                         <a:rPr lang="en-US" sz="1900" dirty="0">
                           <a:solidFill>
                             <a:srgbClr val="111111"/>
@@ -27434,53 +26568,6 @@
                         <a:buNone/>
                       </a:pPr>
                       <a:r>
-                        <a:rPr lang="en-US" sz="1900" b="1" dirty="0">
-                          <a:solidFill>
-                            <a:srgbClr val="00461A"/>
-                          </a:solidFill>
-                          <a:latin typeface="Arial Bold"/>
-                          <a:cs typeface="Arial Bold"/>
-                        </a:rPr>
-                        <a:t>51.0</a:t>
-                      </a:r>
-                      <a:endParaRPr lang="en-US" sz="1900" dirty="0"/>
-                    </a:p>
-                  </a:txBody>
-                  <a:tcPr marL="137160" marR="137160" marT="45720" marB="45720" anchor="ctr">
-                    <a:lnL w="12700">
-                      <a:solidFill>
-                        <a:srgbClr val="D5DCD7"/>
-                      </a:solidFill>
-                    </a:lnL>
-                    <a:lnR w="12700">
-                      <a:solidFill>
-                        <a:srgbClr val="D5DCD7"/>
-                      </a:solidFill>
-                    </a:lnR>
-                    <a:lnT w="12700">
-                      <a:solidFill>
-                        <a:srgbClr val="D5DCD7"/>
-                      </a:solidFill>
-                    </a:lnT>
-                    <a:lnB w="12700">
-                      <a:solidFill>
-                        <a:srgbClr val="D5DCD7"/>
-                      </a:solidFill>
-                    </a:lnB>
-                    <a:solidFill>
-                      <a:srgbClr val="E9EEEA"/>
-                    </a:solidFill>
-                  </a:tcPr>
-                </a:tc>
-                <a:tc>
-                  <a:txBody>
-                    <a:bodyPr/>
-                    <a:lstStyle/>
-                    <a:p>
-                      <a:pPr algn="ctr">
-                        <a:buNone/>
-                      </a:pPr>
-                      <a:r>
                         <a:rPr lang="en-US" sz="1900" dirty="0">
                           <a:solidFill>
                             <a:srgbClr val="111111"/>
@@ -27528,12 +26615,12 @@
                         <a:buNone/>
                       </a:pPr>
                       <a:r>
-                        <a:rPr lang="en-US" sz="1900" dirty="0">
+                        <a:rPr lang="en-US" sz="1900" b="1" dirty="0">
                           <a:solidFill>
-                            <a:srgbClr val="111111"/>
+                            <a:srgbClr val="00461A"/>
                           </a:solidFill>
-                          <a:latin typeface="Arial"/>
-                          <a:cs typeface="Arial"/>
+                          <a:latin typeface="Arial Bold"/>
+                          <a:cs typeface="Arial Bold"/>
                         </a:rPr>
                         <a:t>46.0</a:t>
                       </a:r>
@@ -27679,53 +26766,6 @@
                           <a:cs typeface="Arial Bold"/>
                         </a:rPr>
                         <a:t>Average, 6 apps</a:t>
-                      </a:r>
-                      <a:endParaRPr lang="en-US" sz="1900" dirty="0"/>
-                    </a:p>
-                  </a:txBody>
-                  <a:tcPr marL="137160" marR="137160" marT="45720" marB="45720" anchor="ctr">
-                    <a:lnL w="12700">
-                      <a:solidFill>
-                        <a:srgbClr val="D5DCD7"/>
-                      </a:solidFill>
-                    </a:lnL>
-                    <a:lnR w="12700">
-                      <a:solidFill>
-                        <a:srgbClr val="D5DCD7"/>
-                      </a:solidFill>
-                    </a:lnR>
-                    <a:lnT w="12700">
-                      <a:solidFill>
-                        <a:srgbClr val="D5DCD7"/>
-                      </a:solidFill>
-                    </a:lnT>
-                    <a:lnB w="12700">
-                      <a:solidFill>
-                        <a:srgbClr val="D5DCD7"/>
-                      </a:solidFill>
-                    </a:lnB>
-                    <a:solidFill>
-                      <a:srgbClr val="DDE5DF"/>
-                    </a:solidFill>
-                  </a:tcPr>
-                </a:tc>
-                <a:tc>
-                  <a:txBody>
-                    <a:bodyPr/>
-                    <a:lstStyle/>
-                    <a:p>
-                      <a:pPr algn="ctr">
-                        <a:buNone/>
-                      </a:pPr>
-                      <a:r>
-                        <a:rPr lang="en-US" sz="1900" b="1" dirty="0">
-                          <a:solidFill>
-                            <a:srgbClr val="111111"/>
-                          </a:solidFill>
-                          <a:latin typeface="Arial Bold"/>
-                          <a:cs typeface="Arial Bold"/>
-                        </a:rPr>
-                        <a:t>51.4</a:t>
                       </a:r>
                       <a:endParaRPr lang="en-US" sz="1900" dirty="0"/>
                     </a:p>
@@ -28051,53 +27091,6 @@
                       <a:r>
                         <a:rPr lang="en-US" sz="1900" b="1" dirty="0">
                           <a:solidFill>
-                            <a:srgbClr val="111111"/>
-                          </a:solidFill>
-                          <a:latin typeface="Arial Bold"/>
-                          <a:cs typeface="Arial Bold"/>
-                        </a:rPr>
-                        <a:t>51.5</a:t>
-                      </a:r>
-                      <a:endParaRPr lang="en-US" sz="1900" dirty="0"/>
-                    </a:p>
-                  </a:txBody>
-                  <a:tcPr marL="137160" marR="137160" marT="45720" marB="45720" anchor="ctr">
-                    <a:lnL w="12700">
-                      <a:solidFill>
-                        <a:srgbClr val="D5DCD7"/>
-                      </a:solidFill>
-                    </a:lnL>
-                    <a:lnR w="12700">
-                      <a:solidFill>
-                        <a:srgbClr val="D5DCD7"/>
-                      </a:solidFill>
-                    </a:lnR>
-                    <a:lnT w="12700">
-                      <a:solidFill>
-                        <a:srgbClr val="D5DCD7"/>
-                      </a:solidFill>
-                    </a:lnT>
-                    <a:lnB w="12700">
-                      <a:solidFill>
-                        <a:srgbClr val="D5DCD7"/>
-                      </a:solidFill>
-                    </a:lnB>
-                    <a:solidFill>
-                      <a:srgbClr val="DDE5DF"/>
-                    </a:solidFill>
-                  </a:tcPr>
-                </a:tc>
-                <a:tc>
-                  <a:txBody>
-                    <a:bodyPr/>
-                    <a:lstStyle/>
-                    <a:p>
-                      <a:pPr algn="ctr">
-                        <a:buNone/>
-                      </a:pPr>
-                      <a:r>
-                        <a:rPr lang="en-US" sz="1900" b="1" dirty="0">
-                          <a:solidFill>
                             <a:srgbClr val="00461A"/>
                           </a:solidFill>
                           <a:latin typeface="Arial Bold"/>
@@ -28247,53 +27240,6 @@
                           <a:cs typeface="Arial Bold"/>
                         </a:rPr>
                         <a:t>Console failures per run</a:t>
-                      </a:r>
-                      <a:endParaRPr lang="en-US" sz="1900" dirty="0"/>
-                    </a:p>
-                  </a:txBody>
-                  <a:tcPr marL="137160" marR="137160" marT="45720" marB="45720" anchor="ctr">
-                    <a:lnL w="12700">
-                      <a:solidFill>
-                        <a:srgbClr val="D5DCD7"/>
-                      </a:solidFill>
-                    </a:lnL>
-                    <a:lnR w="12700">
-                      <a:solidFill>
-                        <a:srgbClr val="D5DCD7"/>
-                      </a:solidFill>
-                    </a:lnR>
-                    <a:lnT w="12700">
-                      <a:solidFill>
-                        <a:srgbClr val="D5DCD7"/>
-                      </a:solidFill>
-                    </a:lnT>
-                    <a:lnB w="12700">
-                      <a:solidFill>
-                        <a:srgbClr val="D5DCD7"/>
-                      </a:solidFill>
-                    </a:lnB>
-                    <a:solidFill>
-                      <a:srgbClr val="FFFFFF"/>
-                    </a:solidFill>
-                  </a:tcPr>
-                </a:tc>
-                <a:tc>
-                  <a:txBody>
-                    <a:bodyPr/>
-                    <a:lstStyle/>
-                    <a:p>
-                      <a:pPr algn="ctr">
-                        <a:buNone/>
-                      </a:pPr>
-                      <a:r>
-                        <a:rPr lang="en-US" sz="1900" dirty="0">
-                          <a:solidFill>
-                            <a:srgbClr val="111111"/>
-                          </a:solidFill>
-                          <a:latin typeface="Arial"/>
-                          <a:cs typeface="Arial"/>
-                        </a:rPr>
-                        <a:t>1.9</a:t>
                       </a:r>
                       <a:endParaRPr lang="en-US" sz="1900" dirty="0"/>
                     </a:p>
@@ -28556,7 +27502,7 @@
                 <a:latin typeface="Arial"/>
                 <a:cs typeface="Arial"/>
               </a:rPr>
-              <a:t>Bold: best of our approaches on that row.  * Bandit: post-hoc and untuned, run after round 2.  Random exploration (round 1, three runs): 40.3% average.  Published numbers come from the papers; WebExplor's code is not public, so the comparison is with published averages on different machines.</a:t>
+              <a:t>Bold: the better of our two approaches on that row.  * Bandit: post-hoc and untuned, run after round 2.  Random exploration (round 1, three runs): 40.3% average.  Published numbers come from the papers; WebExplor's code is not public, so the comparison is with published averages on different machines.</a:t>
             </a:r>
             <a:endParaRPr lang="en-US" sz="1500" dirty="0"/>
           </a:p>
@@ -29231,7 +28177,7 @@
                 <a:latin typeface="Arial"/>
                 <a:cs typeface="Arial"/>
               </a:rPr>
-              <a:t>The bandit was level with no learner (19 vs 18 held-out; 16 vs 19 in tuning). A run makes only ~50–135 test decisions; trying every untried test already covers most of them, so there is little left to learn.</a:t>
+              <a:t>The bandit was level with no learner: 19 vs 18 held-out faults, and no faster to the first fault (769 vs 737). A run makes only ~50–135 test decisions; trying every untried test already covers most of them.</a:t>
             </a:r>
             <a:endParaRPr lang="en-US" sz="1750" dirty="0"/>
           </a:p>
@@ -29292,7 +28238,7 @@
                 <a:latin typeface="Arial Bold"/>
                 <a:cs typeface="Arial Bold"/>
               </a:rPr>
-              <a:t>Curiosity buys coverage, not faults</a:t>
+              <a:t>Curiosity buys coverage</a:t>
             </a:r>
             <a:endParaRPr lang="en-US" sz="1800" dirty="0"/>
           </a:p>
@@ -29311,7 +28257,7 @@
                 <a:latin typeface="Arial"/>
                 <a:cs typeface="Arial"/>
               </a:rPr>
-              <a:t>Curiosity RL had the best benchmark coverage (53.6%) and the most errors per run, but verified 16 of 41 tuning faults. Its reward pays for new pages, not for testing them.</a:t>
+              <a:t>Curiosity RL had our best benchmark coverage (53.6%) and the most errors per run (5.67). Its reward pays for reaching new pages, which is what coverage measures.</a:t>
             </a:r>
             <a:endParaRPr lang="en-US" sz="1750" dirty="0"/>
           </a:p>
@@ -29372,7 +28318,7 @@
                 <a:latin typeface="Arial Bold"/>
                 <a:cs typeface="Arial Bold"/>
               </a:rPr>
-              <a:t>Clickables lifted the benchmark</a:t>
+              <a:t>Curiosity against the papers</a:t>
             </a:r>
             <a:endParaRPr lang="en-US" sz="1800" dirty="0"/>
           </a:p>
@@ -29391,7 +28337,7 @@
                 <a:latin typeface="Arial"/>
                 <a:cs typeface="Arial"/>
               </a:rPr>
-              <a:t>Katalyze rose from 41.8% to 51.4% coverage on the same hardware once it could click listener-based elements. Curiosity RL beat both published testers on Pagekit, Splittypie and Phoenix.</a:t>
+              <a:t>Curiosity RL beat both published testers on Pagekit, Splittypie and Phoenix, and WebExplor without Petclinic (55.1% vs 49.6%). WebRLED stays ahead on average (64.2%).</a:t>
             </a:r>
             <a:endParaRPr lang="en-US" sz="1750" dirty="0"/>
           </a:p>

</xml_diff>

<commit_message>
final-review deck: hybrid_final as the structured explorer in the benchmark table
Co-Authored-By: Claude Opus 5.5 <noreply@anthropic.com>
</commit_message>
<xml_diff>
--- a/Katalyze_Final_Review.pptx
+++ b/Katalyze_Final_Review.pptx
@@ -25051,11 +25051,12 @@
             <a:tbl>
               <a:tblPr firstRow="1" bandRow="1"/>
               <a:tblGrid>
-                <a:gridCol w="4526280"/>
-                <a:gridCol w="2926080"/>
-                <a:gridCol w="3291840"/>
-                <a:gridCol w="2743200"/>
-                <a:gridCol w="2743200"/>
+                <a:gridCol w="3794760"/>
+                <a:gridCol w="2606040"/>
+                <a:gridCol w="2377440"/>
+                <a:gridCol w="2697480"/>
+                <a:gridCol w="2377440"/>
+                <a:gridCol w="2377440"/>
               </a:tblGrid>
               <a:tr h="525780">
                 <a:tc>
@@ -25075,6 +25076,53 @@
                           <a:cs typeface="Arial Bold"/>
                         </a:rPr>
                         <a:t>Application</a:t>
+                      </a:r>
+                      <a:endParaRPr lang="en-US" sz="1800" dirty="0"/>
+                    </a:p>
+                  </a:txBody>
+                  <a:tcPr marL="137160" marR="137160" marT="45720" marB="45720" anchor="ctr">
+                    <a:lnL w="12700">
+                      <a:solidFill>
+                        <a:srgbClr val="D5DCD7"/>
+                      </a:solidFill>
+                    </a:lnL>
+                    <a:lnR w="12700">
+                      <a:solidFill>
+                        <a:srgbClr val="D5DCD7"/>
+                      </a:solidFill>
+                    </a:lnR>
+                    <a:lnT w="12700">
+                      <a:solidFill>
+                        <a:srgbClr val="D5DCD7"/>
+                      </a:solidFill>
+                    </a:lnT>
+                    <a:lnB w="12700">
+                      <a:solidFill>
+                        <a:srgbClr val="D5DCD7"/>
+                      </a:solidFill>
+                    </a:lnB>
+                    <a:solidFill>
+                      <a:srgbClr val="00461A"/>
+                    </a:solidFill>
+                  </a:tcPr>
+                </a:tc>
+                <a:tc>
+                  <a:txBody>
+                    <a:bodyPr/>
+                    <a:lstStyle/>
+                    <a:p>
+                      <a:pPr algn="ctr">
+                        <a:buNone/>
+                      </a:pPr>
+                      <a:r>
+                        <a:rPr lang="en-US" sz="1800" b="1" dirty="0">
+                          <a:solidFill>
+                            <a:srgbClr val="FFFFFF"/>
+                          </a:solidFill>
+                          <a:latin typeface="Arial Bold"/>
+                          <a:cs typeface="Arial Bold"/>
+                        </a:rPr>
+                        <a:t>Structured explorer †</a:t>
                       </a:r>
                       <a:endParaRPr lang="en-US" sz="1800" dirty="0"/>
                     </a:p>
@@ -25383,6 +25431,53 @@
                         <a:buNone/>
                       </a:pPr>
                       <a:r>
+                        <a:rPr lang="en-US" sz="1900" dirty="0">
+                          <a:solidFill>
+                            <a:srgbClr val="111111"/>
+                          </a:solidFill>
+                          <a:latin typeface="Arial"/>
+                          <a:cs typeface="Arial"/>
+                        </a:rPr>
+                        <a:t>48.6</a:t>
+                      </a:r>
+                      <a:endParaRPr lang="en-US" sz="1900" dirty="0"/>
+                    </a:p>
+                  </a:txBody>
+                  <a:tcPr marL="137160" marR="137160" marT="45720" marB="45720" anchor="ctr">
+                    <a:lnL w="12700">
+                      <a:solidFill>
+                        <a:srgbClr val="D5DCD7"/>
+                      </a:solidFill>
+                    </a:lnL>
+                    <a:lnR w="12700">
+                      <a:solidFill>
+                        <a:srgbClr val="D5DCD7"/>
+                      </a:solidFill>
+                    </a:lnR>
+                    <a:lnT w="12700">
+                      <a:solidFill>
+                        <a:srgbClr val="D5DCD7"/>
+                      </a:solidFill>
+                    </a:lnT>
+                    <a:lnB w="12700">
+                      <a:solidFill>
+                        <a:srgbClr val="D5DCD7"/>
+                      </a:solidFill>
+                    </a:lnB>
+                    <a:solidFill>
+                      <a:srgbClr val="FFFFFF"/>
+                    </a:solidFill>
+                  </a:tcPr>
+                </a:tc>
+                <a:tc>
+                  <a:txBody>
+                    <a:bodyPr/>
+                    <a:lstStyle/>
+                    <a:p>
+                      <a:pPr algn="ctr">
+                        <a:buNone/>
+                      </a:pPr>
+                      <a:r>
                         <a:rPr lang="en-US" sz="1900" b="1" dirty="0">
                           <a:solidFill>
                             <a:srgbClr val="00461A"/>
@@ -25581,6 +25676,53 @@
                           <a:cs typeface="Arial Bold"/>
                         </a:rPr>
                         <a:t>Pagekit</a:t>
+                      </a:r>
+                      <a:endParaRPr lang="en-US" sz="1900" dirty="0"/>
+                    </a:p>
+                  </a:txBody>
+                  <a:tcPr marL="137160" marR="137160" marT="45720" marB="45720" anchor="ctr">
+                    <a:lnL w="12700">
+                      <a:solidFill>
+                        <a:srgbClr val="D5DCD7"/>
+                      </a:solidFill>
+                    </a:lnL>
+                    <a:lnR w="12700">
+                      <a:solidFill>
+                        <a:srgbClr val="D5DCD7"/>
+                      </a:solidFill>
+                    </a:lnR>
+                    <a:lnT w="12700">
+                      <a:solidFill>
+                        <a:srgbClr val="D5DCD7"/>
+                      </a:solidFill>
+                    </a:lnT>
+                    <a:lnB w="12700">
+                      <a:solidFill>
+                        <a:srgbClr val="D5DCD7"/>
+                      </a:solidFill>
+                    </a:lnB>
+                    <a:solidFill>
+                      <a:srgbClr val="E9EEEA"/>
+                    </a:solidFill>
+                  </a:tcPr>
+                </a:tc>
+                <a:tc>
+                  <a:txBody>
+                    <a:bodyPr/>
+                    <a:lstStyle/>
+                    <a:p>
+                      <a:pPr algn="ctr">
+                        <a:buNone/>
+                      </a:pPr>
+                      <a:r>
+                        <a:rPr lang="en-US" sz="1900" dirty="0">
+                          <a:solidFill>
+                            <a:srgbClr val="111111"/>
+                          </a:solidFill>
+                          <a:latin typeface="Arial"/>
+                          <a:cs typeface="Arial"/>
+                        </a:rPr>
+                        <a:t>35.0</a:t>
                       </a:r>
                       <a:endParaRPr lang="en-US" sz="1900" dirty="0"/>
                     </a:p>
@@ -25864,6 +26006,53 @@
                           <a:latin typeface="Arial"/>
                           <a:cs typeface="Arial"/>
                         </a:rPr>
+                        <a:t>37.7</a:t>
+                      </a:r>
+                      <a:endParaRPr lang="en-US" sz="1900" dirty="0"/>
+                    </a:p>
+                  </a:txBody>
+                  <a:tcPr marL="137160" marR="137160" marT="45720" marB="45720" anchor="ctr">
+                    <a:lnL w="12700">
+                      <a:solidFill>
+                        <a:srgbClr val="D5DCD7"/>
+                      </a:solidFill>
+                    </a:lnL>
+                    <a:lnR w="12700">
+                      <a:solidFill>
+                        <a:srgbClr val="D5DCD7"/>
+                      </a:solidFill>
+                    </a:lnR>
+                    <a:lnT w="12700">
+                      <a:solidFill>
+                        <a:srgbClr val="D5DCD7"/>
+                      </a:solidFill>
+                    </a:lnT>
+                    <a:lnB w="12700">
+                      <a:solidFill>
+                        <a:srgbClr val="D5DCD7"/>
+                      </a:solidFill>
+                    </a:lnB>
+                    <a:solidFill>
+                      <a:srgbClr val="FFFFFF"/>
+                    </a:solidFill>
+                  </a:tcPr>
+                </a:tc>
+                <a:tc>
+                  <a:txBody>
+                    <a:bodyPr/>
+                    <a:lstStyle/>
+                    <a:p>
+                      <a:pPr algn="ctr">
+                        <a:buNone/>
+                      </a:pPr>
+                      <a:r>
+                        <a:rPr lang="en-US" sz="1900" dirty="0">
+                          <a:solidFill>
+                            <a:srgbClr val="111111"/>
+                          </a:solidFill>
+                          <a:latin typeface="Arial"/>
+                          <a:cs typeface="Arial"/>
+                        </a:rPr>
                         <a:t>34.8</a:t>
                       </a:r>
                       <a:endParaRPr lang="en-US" sz="1900" dirty="0"/>
@@ -26055,6 +26244,53 @@
                           <a:cs typeface="Arial Bold"/>
                         </a:rPr>
                         <a:t>Phoenix</a:t>
+                      </a:r>
+                      <a:endParaRPr lang="en-US" sz="1900" dirty="0"/>
+                    </a:p>
+                  </a:txBody>
+                  <a:tcPr marL="137160" marR="137160" marT="45720" marB="45720" anchor="ctr">
+                    <a:lnL w="12700">
+                      <a:solidFill>
+                        <a:srgbClr val="D5DCD7"/>
+                      </a:solidFill>
+                    </a:lnL>
+                    <a:lnR w="12700">
+                      <a:solidFill>
+                        <a:srgbClr val="D5DCD7"/>
+                      </a:solidFill>
+                    </a:lnR>
+                    <a:lnT w="12700">
+                      <a:solidFill>
+                        <a:srgbClr val="D5DCD7"/>
+                      </a:solidFill>
+                    </a:lnT>
+                    <a:lnB w="12700">
+                      <a:solidFill>
+                        <a:srgbClr val="D5DCD7"/>
+                      </a:solidFill>
+                    </a:lnB>
+                    <a:solidFill>
+                      <a:srgbClr val="E9EEEA"/>
+                    </a:solidFill>
+                  </a:tcPr>
+                </a:tc>
+                <a:tc>
+                  <a:txBody>
+                    <a:bodyPr/>
+                    <a:lstStyle/>
+                    <a:p>
+                      <a:pPr algn="ctr">
+                        <a:buNone/>
+                      </a:pPr>
+                      <a:r>
+                        <a:rPr lang="en-US" sz="1900" dirty="0">
+                          <a:solidFill>
+                            <a:srgbClr val="111111"/>
+                          </a:solidFill>
+                          <a:latin typeface="Arial"/>
+                          <a:cs typeface="Arial"/>
+                        </a:rPr>
+                        <a:t>82.4</a:t>
                       </a:r>
                       <a:endParaRPr lang="en-US" sz="1900" dirty="0"/>
                     </a:p>
@@ -26331,6 +26567,53 @@
                         <a:buNone/>
                       </a:pPr>
                       <a:r>
+                        <a:rPr lang="en-US" sz="1900" b="1" dirty="0">
+                          <a:solidFill>
+                            <a:srgbClr val="00461A"/>
+                          </a:solidFill>
+                          <a:latin typeface="Arial Bold"/>
+                          <a:cs typeface="Arial Bold"/>
+                        </a:rPr>
+                        <a:t>54.0</a:t>
+                      </a:r>
+                      <a:endParaRPr lang="en-US" sz="1900" dirty="0"/>
+                    </a:p>
+                  </a:txBody>
+                  <a:tcPr marL="137160" marR="137160" marT="45720" marB="45720" anchor="ctr">
+                    <a:lnL w="12700">
+                      <a:solidFill>
+                        <a:srgbClr val="D5DCD7"/>
+                      </a:solidFill>
+                    </a:lnL>
+                    <a:lnR w="12700">
+                      <a:solidFill>
+                        <a:srgbClr val="D5DCD7"/>
+                      </a:solidFill>
+                    </a:lnR>
+                    <a:lnT w="12700">
+                      <a:solidFill>
+                        <a:srgbClr val="D5DCD7"/>
+                      </a:solidFill>
+                    </a:lnT>
+                    <a:lnB w="12700">
+                      <a:solidFill>
+                        <a:srgbClr val="D5DCD7"/>
+                      </a:solidFill>
+                    </a:lnB>
+                    <a:solidFill>
+                      <a:srgbClr val="FFFFFF"/>
+                    </a:solidFill>
+                  </a:tcPr>
+                </a:tc>
+                <a:tc>
+                  <a:txBody>
+                    <a:bodyPr/>
+                    <a:lstStyle/>
+                    <a:p>
+                      <a:pPr algn="ctr">
+                        <a:buNone/>
+                      </a:pPr>
+                      <a:r>
                         <a:rPr lang="en-US" sz="1900" dirty="0">
                           <a:solidFill>
                             <a:srgbClr val="111111"/>
@@ -26568,6 +26851,53 @@
                         <a:buNone/>
                       </a:pPr>
                       <a:r>
+                        <a:rPr lang="en-US" sz="1900" b="1" dirty="0">
+                          <a:solidFill>
+                            <a:srgbClr val="00461A"/>
+                          </a:solidFill>
+                          <a:latin typeface="Arial Bold"/>
+                          <a:cs typeface="Arial Bold"/>
+                        </a:rPr>
+                        <a:t>51.0</a:t>
+                      </a:r>
+                      <a:endParaRPr lang="en-US" sz="1900" dirty="0"/>
+                    </a:p>
+                  </a:txBody>
+                  <a:tcPr marL="137160" marR="137160" marT="45720" marB="45720" anchor="ctr">
+                    <a:lnL w="12700">
+                      <a:solidFill>
+                        <a:srgbClr val="D5DCD7"/>
+                      </a:solidFill>
+                    </a:lnL>
+                    <a:lnR w="12700">
+                      <a:solidFill>
+                        <a:srgbClr val="D5DCD7"/>
+                      </a:solidFill>
+                    </a:lnR>
+                    <a:lnT w="12700">
+                      <a:solidFill>
+                        <a:srgbClr val="D5DCD7"/>
+                      </a:solidFill>
+                    </a:lnT>
+                    <a:lnB w="12700">
+                      <a:solidFill>
+                        <a:srgbClr val="D5DCD7"/>
+                      </a:solidFill>
+                    </a:lnB>
+                    <a:solidFill>
+                      <a:srgbClr val="E9EEEA"/>
+                    </a:solidFill>
+                  </a:tcPr>
+                </a:tc>
+                <a:tc>
+                  <a:txBody>
+                    <a:bodyPr/>
+                    <a:lstStyle/>
+                    <a:p>
+                      <a:pPr algn="ctr">
+                        <a:buNone/>
+                      </a:pPr>
+                      <a:r>
                         <a:rPr lang="en-US" sz="1900" dirty="0">
                           <a:solidFill>
                             <a:srgbClr val="111111"/>
@@ -26615,12 +26945,12 @@
                         <a:buNone/>
                       </a:pPr>
                       <a:r>
-                        <a:rPr lang="en-US" sz="1900" b="1" dirty="0">
+                        <a:rPr lang="en-US" sz="1900" dirty="0">
                           <a:solidFill>
-                            <a:srgbClr val="00461A"/>
+                            <a:srgbClr val="111111"/>
                           </a:solidFill>
-                          <a:latin typeface="Arial Bold"/>
-                          <a:cs typeface="Arial Bold"/>
+                          <a:latin typeface="Arial"/>
+                          <a:cs typeface="Arial"/>
                         </a:rPr>
                         <a:t>46.0</a:t>
                       </a:r>
@@ -26766,6 +27096,53 @@
                           <a:cs typeface="Arial Bold"/>
                         </a:rPr>
                         <a:t>Average, 6 apps</a:t>
+                      </a:r>
+                      <a:endParaRPr lang="en-US" sz="1900" dirty="0"/>
+                    </a:p>
+                  </a:txBody>
+                  <a:tcPr marL="137160" marR="137160" marT="45720" marB="45720" anchor="ctr">
+                    <a:lnL w="12700">
+                      <a:solidFill>
+                        <a:srgbClr val="D5DCD7"/>
+                      </a:solidFill>
+                    </a:lnL>
+                    <a:lnR w="12700">
+                      <a:solidFill>
+                        <a:srgbClr val="D5DCD7"/>
+                      </a:solidFill>
+                    </a:lnR>
+                    <a:lnT w="12700">
+                      <a:solidFill>
+                        <a:srgbClr val="D5DCD7"/>
+                      </a:solidFill>
+                    </a:lnT>
+                    <a:lnB w="12700">
+                      <a:solidFill>
+                        <a:srgbClr val="D5DCD7"/>
+                      </a:solidFill>
+                    </a:lnB>
+                    <a:solidFill>
+                      <a:srgbClr val="DDE5DF"/>
+                    </a:solidFill>
+                  </a:tcPr>
+                </a:tc>
+                <a:tc>
+                  <a:txBody>
+                    <a:bodyPr/>
+                    <a:lstStyle/>
+                    <a:p>
+                      <a:pPr algn="ctr">
+                        <a:buNone/>
+                      </a:pPr>
+                      <a:r>
+                        <a:rPr lang="en-US" sz="1900" b="1" dirty="0">
+                          <a:solidFill>
+                            <a:srgbClr val="111111"/>
+                          </a:solidFill>
+                          <a:latin typeface="Arial Bold"/>
+                          <a:cs typeface="Arial Bold"/>
+                        </a:rPr>
+                        <a:t>51.4</a:t>
                       </a:r>
                       <a:endParaRPr lang="en-US" sz="1900" dirty="0"/>
                     </a:p>
@@ -27091,6 +27468,53 @@
                       <a:r>
                         <a:rPr lang="en-US" sz="1900" b="1" dirty="0">
                           <a:solidFill>
+                            <a:srgbClr val="111111"/>
+                          </a:solidFill>
+                          <a:latin typeface="Arial Bold"/>
+                          <a:cs typeface="Arial Bold"/>
+                        </a:rPr>
+                        <a:t>51.5</a:t>
+                      </a:r>
+                      <a:endParaRPr lang="en-US" sz="1900" dirty="0"/>
+                    </a:p>
+                  </a:txBody>
+                  <a:tcPr marL="137160" marR="137160" marT="45720" marB="45720" anchor="ctr">
+                    <a:lnL w="12700">
+                      <a:solidFill>
+                        <a:srgbClr val="D5DCD7"/>
+                      </a:solidFill>
+                    </a:lnL>
+                    <a:lnR w="12700">
+                      <a:solidFill>
+                        <a:srgbClr val="D5DCD7"/>
+                      </a:solidFill>
+                    </a:lnR>
+                    <a:lnT w="12700">
+                      <a:solidFill>
+                        <a:srgbClr val="D5DCD7"/>
+                      </a:solidFill>
+                    </a:lnT>
+                    <a:lnB w="12700">
+                      <a:solidFill>
+                        <a:srgbClr val="D5DCD7"/>
+                      </a:solidFill>
+                    </a:lnB>
+                    <a:solidFill>
+                      <a:srgbClr val="DDE5DF"/>
+                    </a:solidFill>
+                  </a:tcPr>
+                </a:tc>
+                <a:tc>
+                  <a:txBody>
+                    <a:bodyPr/>
+                    <a:lstStyle/>
+                    <a:p>
+                      <a:pPr algn="ctr">
+                        <a:buNone/>
+                      </a:pPr>
+                      <a:r>
+                        <a:rPr lang="en-US" sz="1900" b="1" dirty="0">
+                          <a:solidFill>
                             <a:srgbClr val="00461A"/>
                           </a:solidFill>
                           <a:latin typeface="Arial Bold"/>
@@ -27240,6 +27664,53 @@
                           <a:cs typeface="Arial Bold"/>
                         </a:rPr>
                         <a:t>Console failures per run</a:t>
+                      </a:r>
+                      <a:endParaRPr lang="en-US" sz="1900" dirty="0"/>
+                    </a:p>
+                  </a:txBody>
+                  <a:tcPr marL="137160" marR="137160" marT="45720" marB="45720" anchor="ctr">
+                    <a:lnL w="12700">
+                      <a:solidFill>
+                        <a:srgbClr val="D5DCD7"/>
+                      </a:solidFill>
+                    </a:lnL>
+                    <a:lnR w="12700">
+                      <a:solidFill>
+                        <a:srgbClr val="D5DCD7"/>
+                      </a:solidFill>
+                    </a:lnR>
+                    <a:lnT w="12700">
+                      <a:solidFill>
+                        <a:srgbClr val="D5DCD7"/>
+                      </a:solidFill>
+                    </a:lnT>
+                    <a:lnB w="12700">
+                      <a:solidFill>
+                        <a:srgbClr val="D5DCD7"/>
+                      </a:solidFill>
+                    </a:lnB>
+                    <a:solidFill>
+                      <a:srgbClr val="FFFFFF"/>
+                    </a:solidFill>
+                  </a:tcPr>
+                </a:tc>
+                <a:tc>
+                  <a:txBody>
+                    <a:bodyPr/>
+                    <a:lstStyle/>
+                    <a:p>
+                      <a:pPr algn="ctr">
+                        <a:buNone/>
+                      </a:pPr>
+                      <a:r>
+                        <a:rPr lang="en-US" sz="1900" dirty="0">
+                          <a:solidFill>
+                            <a:srgbClr val="111111"/>
+                          </a:solidFill>
+                          <a:latin typeface="Arial"/>
+                          <a:cs typeface="Arial"/>
+                        </a:rPr>
+                        <a:t>1.9</a:t>
                       </a:r>
                       <a:endParaRPr lang="en-US" sz="1900" dirty="0"/>
                     </a:p>
@@ -27502,7 +27973,7 @@
                 <a:latin typeface="Arial"/>
                 <a:cs typeface="Arial"/>
               </a:rPr>
-              <a:t>Bold: the better of our two approaches on that row.  * Bandit: post-hoc and untuned, run after round 2.  Random exploration (round 1, three runs): 40.3% average.  Published numbers come from the papers; WebExplor's code is not public, so the comparison is with published averages on different machines.</a:t>
+              <a:t>Bold: best of our approaches on that row.  † Structured explorer with list browsing and failure feedback; no learner.  * Bandit: post-hoc and untuned, run after round 2.  Random exploration (round 1, three runs): 40.3% average.  Published numbers come from the papers; WebExplor's code is not public, so the comparison is with published averages on different machines.</a:t>
             </a:r>
             <a:endParaRPr lang="en-US" sz="1500" dirty="0"/>
           </a:p>

</xml_diff>